<commit_message>
mcs 18 rural macro
</commit_message>
<xml_diff>
--- a/slides/Multi_Objective_RAN_Slice_Optimization_and_TOPSIS_Ranking.pptx
+++ b/slides/Multi_Objective_RAN_Slice_Optimization_and_TOPSIS_Ranking.pptx
@@ -218,7 +218,7 @@
           <a:p>
             <a:fld id="{004D79B1-6B7F-4B16-809B-3FCFA3C93DEF}" type="datetimeFigureOut">
               <a:rPr lang="en-US" smtClean="0"/>
-              <a:t>6/8/2026</a:t>
+              <a:t>6/10/2026</a:t>
             </a:fld>
             <a:endParaRPr lang="en-US"/>
           </a:p>
@@ -396,7 +396,7 @@
           <a:p>
             <a:fld id="{68A8A259-EC5C-486F-8E25-9A7145B17D36}" type="datetimeFigureOut">
               <a:rPr lang="en-US" smtClean="0"/>
-              <a:t>6/8/2026</a:t>
+              <a:t>6/10/2026</a:t>
             </a:fld>
             <a:endParaRPr lang="en-US"/>
           </a:p>
@@ -4749,92 +4749,6 @@
           </a:p>
         </p:txBody>
       </p:sp>
-      <p:sp>
-        <p:nvSpPr>
-          <p:cNvPr id="3" name="Text 1">
-            <a:extLst>
-              <a:ext uri="{FF2B5EF4-FFF2-40B4-BE49-F238E27FC236}">
-                <a16:creationId xmlns:a16="http://schemas.microsoft.com/office/drawing/2014/main" id="{6147F672-3849-FCB7-BD20-72E5B35A5E01}"/>
-              </a:ext>
-            </a:extLst>
-          </p:cNvPr>
-          <p:cNvSpPr/>
-          <p:nvPr/>
-        </p:nvSpPr>
-        <p:spPr>
-          <a:xfrm>
-            <a:off x="4811099" y="283464"/>
-            <a:ext cx="3108960" cy="256032"/>
-          </a:xfrm>
-          <a:prstGeom prst="rect">
-            <a:avLst/>
-          </a:prstGeom>
-          <a:noFill/>
-          <a:ln/>
-        </p:spPr>
-        <p:txBody>
-          <a:bodyPr wrap="square" lIns="0" tIns="0" rIns="0" bIns="0" rtlCol="0" anchor="ctr"/>
-          <a:lstStyle/>
-          <a:p>
-            <a:pPr marL="0" indent="0">
-              <a:buNone/>
-            </a:pPr>
-            <a:r>
-              <a:rPr lang="en-US" sz="1250" b="1" dirty="0">
-                <a:solidFill>
-                  <a:srgbClr val="2F6FDB"/>
-                </a:solidFill>
-              </a:rPr>
-              <a:t>TOPSIS Algorithm • eMBB</a:t>
-            </a:r>
-            <a:endParaRPr lang="en-US" sz="1250" dirty="0"/>
-          </a:p>
-        </p:txBody>
-      </p:sp>
-      <p:sp>
-        <p:nvSpPr>
-          <p:cNvPr id="4" name="Text 2">
-            <a:extLst>
-              <a:ext uri="{FF2B5EF4-FFF2-40B4-BE49-F238E27FC236}">
-                <a16:creationId xmlns:a16="http://schemas.microsoft.com/office/drawing/2014/main" id="{36F50D53-0B90-0102-F33D-20A818016E76}"/>
-              </a:ext>
-            </a:extLst>
-          </p:cNvPr>
-          <p:cNvSpPr/>
-          <p:nvPr/>
-        </p:nvSpPr>
-        <p:spPr>
-          <a:xfrm>
-            <a:off x="502920" y="640080"/>
-            <a:ext cx="8046720" cy="411480"/>
-          </a:xfrm>
-          <a:prstGeom prst="rect">
-            <a:avLst/>
-          </a:prstGeom>
-          <a:noFill/>
-          <a:ln/>
-        </p:spPr>
-        <p:txBody>
-          <a:bodyPr wrap="square" lIns="0" tIns="0" rIns="0" bIns="0" rtlCol="0" anchor="ctr">
-            <a:normAutofit/>
-          </a:bodyPr>
-          <a:lstStyle/>
-          <a:p>
-            <a:pPr marL="0" indent="0">
-              <a:buNone/>
-            </a:pPr>
-            <a:r>
-              <a:rPr lang="en-US" sz="2500" b="1" dirty="0">
-                <a:solidFill>
-                  <a:srgbClr val="111827"/>
-                </a:solidFill>
-              </a:rPr>
-              <a:t>Media-Flex — best ranked offer</a:t>
-            </a:r>
-            <a:endParaRPr lang="en-US" sz="2500" dirty="0"/>
-          </a:p>
-        </p:txBody>
-      </p:sp>
       <p:pic>
         <p:nvPicPr>
           <p:cNvPr id="74" name="Picture 2">
@@ -6798,7 +6712,7 @@
                 </a:solidFill>
                 <a:latin typeface="Aptos" pitchFamily="34" charset="0"/>
               </a:rPr>
-              <a:t>4</a:t>
+              <a:t>3</a:t>
             </a:r>
             <a:endParaRPr lang="en-US" sz="1100" dirty="0"/>
           </a:p>
@@ -13919,22 +13833,11 @@
           <a:p>
             <a:r>
               <a:rPr lang="en-US" sz="1100" dirty="0">
-                <a:solidFill>
-                  <a:srgbClr val="111827"/>
-                </a:solidFill>
                 <a:latin typeface="Aptos" pitchFamily="34" charset="0"/>
                 <a:ea typeface="Aptos" pitchFamily="34" charset="-122"/>
                 <a:cs typeface="Aptos" pitchFamily="34" charset="-120"/>
               </a:rPr>
-              <a:t>€</a:t>
-            </a:r>
-            <a:r>
-              <a:rPr lang="en-US" sz="1100" dirty="0">
-                <a:latin typeface="Aptos" pitchFamily="34" charset="0"/>
-                <a:ea typeface="Aptos" pitchFamily="34" charset="-122"/>
-                <a:cs typeface="Aptos" pitchFamily="34" charset="-120"/>
-              </a:rPr>
-              <a:t>4.556 W</a:t>
+              <a:t>4.558 W</a:t>
             </a:r>
             <a:endParaRPr lang="en-US" sz="1100" dirty="0"/>
           </a:p>
@@ -15777,7 +15680,7 @@
                 <a:ea typeface="Aptos" pitchFamily="34" charset="-122"/>
                 <a:cs typeface="Aptos" pitchFamily="34" charset="-120"/>
               </a:rPr>
-              <a:t>34.393</a:t>
+              <a:t>34.394</a:t>
             </a:r>
             <a:endParaRPr lang="en-US" sz="1050" dirty="0"/>
           </a:p>
@@ -17469,7 +17372,7 @@
         </p:nvSpPr>
         <p:spPr>
           <a:xfrm>
-            <a:off x="2193410" y="3927516"/>
+            <a:off x="2193410" y="3901947"/>
             <a:ext cx="1014984" cy="265176"/>
           </a:xfrm>
           <a:prstGeom prst="rect">
@@ -17513,7 +17416,7 @@
         </p:nvSpPr>
         <p:spPr>
           <a:xfrm>
-            <a:off x="3097819" y="3890094"/>
+            <a:off x="3097819" y="3867234"/>
             <a:ext cx="1225296" cy="384048"/>
           </a:xfrm>
           <a:prstGeom prst="rect">
@@ -17640,7 +17543,7 @@
         </p:nvSpPr>
         <p:spPr>
           <a:xfrm>
-            <a:off x="4373407" y="3992201"/>
+            <a:off x="4373407" y="4017093"/>
             <a:ext cx="886968" cy="265176"/>
           </a:xfrm>
           <a:prstGeom prst="rect">
@@ -18044,7 +17947,7 @@
                 <a:ea typeface="Aptos" pitchFamily="34" charset="-122"/>
                 <a:cs typeface="Aptos" pitchFamily="34" charset="-120"/>
               </a:rPr>
-              <a:t>Offer 4  •  0.9568</a:t>
+              <a:t>Offer 3  •  0.9568</a:t>
             </a:r>
             <a:endParaRPr lang="en-US" sz="1650" dirty="0"/>
           </a:p>
@@ -18955,8 +18858,8 @@
         </p:nvSpPr>
         <p:spPr>
           <a:xfrm>
-            <a:off x="6781800" y="3502321"/>
-            <a:ext cx="3794760" cy="384048"/>
+            <a:off x="6781800" y="3446272"/>
+            <a:ext cx="3794760" cy="440097"/>
           </a:xfrm>
           <a:prstGeom prst="rect">
             <a:avLst/>
@@ -19007,7 +18910,7 @@
           <a:p>
             <a:r>
               <a:rPr lang="en-US" sz="1400" dirty="0"/>
-              <a:t>0.699</a:t>
+              <a:t>0.6993</a:t>
             </a:r>
           </a:p>
           <a:p>
@@ -19581,7 +19484,7 @@
                 <a:ea typeface="Aptos" pitchFamily="34" charset="-122"/>
                 <a:cs typeface="Aptos" pitchFamily="34" charset="-120"/>
               </a:rPr>
-              <a:t>5.786 W</a:t>
+              <a:t>5.787 W</a:t>
             </a:r>
             <a:endParaRPr lang="en-US" sz="1100" dirty="0"/>
           </a:p>
@@ -21633,7 +21536,7 @@
                 <a:ea typeface="Aptos" pitchFamily="34" charset="-122"/>
                 <a:cs typeface="Aptos" pitchFamily="34" charset="-120"/>
               </a:rPr>
-              <a:t>10.386</a:t>
+              <a:t>10.385</a:t>
             </a:r>
             <a:endParaRPr lang="en-US" sz="1050" dirty="0">
               <a:solidFill>
@@ -22231,7 +22134,7 @@
         </p:nvSpPr>
         <p:spPr>
           <a:xfrm>
-            <a:off x="6286500" y="3127248"/>
+            <a:off x="6286500" y="3200400"/>
             <a:ext cx="832104" cy="265176"/>
           </a:xfrm>
           <a:prstGeom prst="rect">
@@ -22242,7 +22145,7 @@
         </p:spPr>
         <p:txBody>
           <a:bodyPr wrap="square" lIns="0" tIns="0" rIns="0" bIns="0" rtlCol="0" anchor="ctr">
-            <a:normAutofit fontScale="92500" lnSpcReduction="20000"/>
+            <a:normAutofit fontScale="77500" lnSpcReduction="20000"/>
           </a:bodyPr>
           <a:lstStyle/>
           <a:p>
@@ -22254,11 +22157,15 @@
           <a:p>
             <a:pPr algn="ctr"/>
             <a:r>
-              <a:rPr lang="en-US" sz="1050" dirty="0">
-                <a:latin typeface="Aptos" panose="020B0004020202020204" pitchFamily="34" charset="0"/>
-              </a:rPr>
-              <a:t>7.548</a:t>
-            </a:r>
+              <a:rPr lang="en-US" sz="1500" dirty="0"/>
+              <a:t>37.548</a:t>
+            </a:r>
+          </a:p>
+          <a:p>
+            <a:pPr algn="ctr"/>
+            <a:endParaRPr lang="en-US" sz="1050" dirty="0">
+              <a:latin typeface="Aptos" panose="020B0004020202020204" pitchFamily="34" charset="0"/>
+            </a:endParaRPr>
           </a:p>
           <a:p>
             <a:pPr algn="ctr"/>

</xml_diff>